<commit_message>
Regenerate the three deliverables with real fonts and, for the client deck, real trend photography
Instagram carousel and prospecting deck now declare the actual Libre
Baskerville/JetBrains Mono font names (bundled in brand-guidelines)
instead of the Cambria/Courier New QA fallback.

Client material's Trends section now uses the real background photos
extracted from the agosto_26 report PDF (extract_report_photos.py) and
sharpened/upscaled for real (image-enhancer), instead of flat lime cards.
Confirmed those four photos are third-party brand campaign stills (Loewe,
Heineken, Charlotte Tilbury/F1, Skol), so they stay in the client-only
deck per the new image-provenance rule documented in SKILL.md - the
Instagram carousel and prospecting deck are unchanged content-wise since
no rights-safe imagery is available for them yet.

Co-Authored-By: Claude Sonnet 5 <noreply@anthropic.com>
Claude-Session: https://claude.ai/code/session_011ESx8gvmPcKzkkbhXuy6a7
</commit_message>
<xml_diff>
--- a/entregas-agosto26/apresentacao-prospeccao-agosto26.pptx
+++ b/entregas-agosto26/apresentacao-prospeccao-agosto26.pptx
@@ -4225,9 +4225,9 @@
                 <a:solidFill>
                   <a:srgbClr val="DAFF94"/>
                 </a:solidFill>
-                <a:latin typeface="Cambria" pitchFamily="34" charset="0"/>
-                <a:ea typeface="Cambria" pitchFamily="34" charset="-122"/>
-                <a:cs typeface="Cambria" pitchFamily="34" charset="-120"/>
+                <a:latin typeface="Libre Baskerville" pitchFamily="34" charset="0"/>
+                <a:ea typeface="Libre Baskerville" pitchFamily="34" charset="-122"/>
+                <a:cs typeface="Libre Baskerville" pitchFamily="34" charset="-120"/>
               </a:rPr>
               <a:t>Inteligência de mercado a serviço da sua marca.</a:t>
             </a:r>
@@ -4264,9 +4264,9 @@
                 <a:solidFill>
                   <a:srgbClr val="888888"/>
                 </a:solidFill>
-                <a:latin typeface="Courier New" pitchFamily="34" charset="0"/>
-                <a:ea typeface="Courier New" pitchFamily="34" charset="-122"/>
-                <a:cs typeface="Courier New" pitchFamily="34" charset="-120"/>
+                <a:latin typeface="JetBrains Mono" pitchFamily="34" charset="0"/>
+                <a:ea typeface="JetBrains Mono" pitchFamily="34" charset="-122"/>
+                <a:cs typeface="JetBrains Mono" pitchFamily="34" charset="-120"/>
               </a:rPr>
               <a:t>apresentação de prospecção _ agosto_26</a:t>
             </a:r>
@@ -6831,9 +6831,9 @@
                 <a:solidFill>
                   <a:srgbClr val="FFFFFF"/>
                 </a:solidFill>
-                <a:latin typeface="Cambria" pitchFamily="34" charset="0"/>
-                <a:ea typeface="Cambria" pitchFamily="34" charset="-122"/>
-                <a:cs typeface="Cambria" pitchFamily="34" charset="-120"/>
+                <a:latin typeface="Libre Baskerville" pitchFamily="34" charset="0"/>
+                <a:ea typeface="Libre Baskerville" pitchFamily="34" charset="-122"/>
+                <a:cs typeface="Libre Baskerville" pitchFamily="34" charset="-120"/>
               </a:rPr>
               <a:t>Vamos conversar sobre o que</a:t>
             </a:r>
@@ -6848,9 +6848,9 @@
                 <a:solidFill>
                   <a:srgbClr val="FFFFFF"/>
                 </a:solidFill>
-                <a:latin typeface="Cambria" pitchFamily="34" charset="0"/>
-                <a:ea typeface="Cambria" pitchFamily="34" charset="-122"/>
-                <a:cs typeface="Cambria" pitchFamily="34" charset="-120"/>
+                <a:latin typeface="Libre Baskerville" pitchFamily="34" charset="0"/>
+                <a:ea typeface="Libre Baskerville" pitchFamily="34" charset="-122"/>
+                <a:cs typeface="Libre Baskerville" pitchFamily="34" charset="-120"/>
               </a:rPr>
               <a:t>essas tendências significam</a:t>
             </a:r>
@@ -6865,9 +6865,9 @@
                 <a:solidFill>
                   <a:srgbClr val="FFFFFF"/>
                 </a:solidFill>
-                <a:latin typeface="Cambria" pitchFamily="34" charset="0"/>
-                <a:ea typeface="Cambria" pitchFamily="34" charset="-122"/>
-                <a:cs typeface="Cambria" pitchFamily="34" charset="-120"/>
+                <a:latin typeface="Libre Baskerville" pitchFamily="34" charset="0"/>
+                <a:ea typeface="Libre Baskerville" pitchFamily="34" charset="-122"/>
+                <a:cs typeface="Libre Baskerville" pitchFamily="34" charset="-120"/>
               </a:rPr>
               <a:t>pra sua marca?</a:t>
             </a:r>
@@ -6904,9 +6904,9 @@
                 <a:solidFill>
                   <a:srgbClr val="DAFF94"/>
                 </a:solidFill>
-                <a:latin typeface="Courier New" pitchFamily="34" charset="0"/>
-                <a:ea typeface="Courier New" pitchFamily="34" charset="-122"/>
-                <a:cs typeface="Courier New" pitchFamily="34" charset="-120"/>
+                <a:latin typeface="JetBrains Mono" pitchFamily="34" charset="0"/>
+                <a:ea typeface="JetBrains Mono" pitchFamily="34" charset="-122"/>
+                <a:cs typeface="JetBrains Mono" pitchFamily="34" charset="-120"/>
               </a:rPr>
               <a:t>[ contato@ / site / whatsapp — preencher ]</a:t>
             </a:r>
@@ -6999,9 +6999,9 @@
                 <a:solidFill>
                   <a:srgbClr val="DAFF94"/>
                 </a:solidFill>
-                <a:latin typeface="Courier New" pitchFamily="34" charset="0"/>
-                <a:ea typeface="Courier New" pitchFamily="34" charset="-122"/>
-                <a:cs typeface="Courier New" pitchFamily="34" charset="-120"/>
+                <a:latin typeface="JetBrains Mono" pitchFamily="34" charset="0"/>
+                <a:ea typeface="JetBrains Mono" pitchFamily="34" charset="-122"/>
+                <a:cs typeface="JetBrains Mono" pitchFamily="34" charset="-120"/>
               </a:rPr>
               <a:t>O PONTO DE PARTIDA</a:t>
             </a:r>
@@ -7038,9 +7038,9 @@
                 <a:solidFill>
                   <a:srgbClr val="FFFFFF"/>
                 </a:solidFill>
-                <a:latin typeface="Cambria" pitchFamily="34" charset="0"/>
-                <a:ea typeface="Cambria" pitchFamily="34" charset="-122"/>
-                <a:cs typeface="Cambria" pitchFamily="34" charset="-120"/>
+                <a:latin typeface="Libre Baskerville" pitchFamily="34" charset="0"/>
+                <a:ea typeface="Libre Baskerville" pitchFamily="34" charset="-122"/>
+                <a:cs typeface="Libre Baskerville" pitchFamily="34" charset="-120"/>
               </a:rPr>
               <a:t>O mercado não para de mudar.</a:t>
             </a:r>
@@ -7055,9 +7055,9 @@
                 <a:solidFill>
                   <a:srgbClr val="FFFFFF"/>
                 </a:solidFill>
-                <a:latin typeface="Cambria" pitchFamily="34" charset="0"/>
-                <a:ea typeface="Cambria" pitchFamily="34" charset="-122"/>
-                <a:cs typeface="Cambria" pitchFamily="34" charset="-120"/>
+                <a:latin typeface="Libre Baskerville" pitchFamily="34" charset="0"/>
+                <a:ea typeface="Libre Baskerville" pitchFamily="34" charset="-122"/>
+                <a:cs typeface="Libre Baskerville" pitchFamily="34" charset="-120"/>
               </a:rPr>
               <a:t>A sua marca está lendo isso em tempo real?</a:t>
             </a:r>
@@ -7121,9 +7121,9 @@
                 <a:solidFill>
                   <a:srgbClr val="DAFF94"/>
                 </a:solidFill>
-                <a:latin typeface="Cambria" pitchFamily="34" charset="0"/>
-                <a:ea typeface="Cambria" pitchFamily="34" charset="-122"/>
-                <a:cs typeface="Cambria" pitchFamily="34" charset="-120"/>
+                <a:latin typeface="Libre Baskerville" pitchFamily="34" charset="0"/>
+                <a:ea typeface="Libre Baskerville" pitchFamily="34" charset="-122"/>
+                <a:cs typeface="Libre Baskerville" pitchFamily="34" charset="-120"/>
               </a:rPr>
               <a:t>200%</a:t>
             </a:r>
@@ -7226,9 +7226,9 @@
                 <a:solidFill>
                   <a:srgbClr val="DAFF94"/>
                 </a:solidFill>
-                <a:latin typeface="Cambria" pitchFamily="34" charset="0"/>
-                <a:ea typeface="Cambria" pitchFamily="34" charset="-122"/>
-                <a:cs typeface="Cambria" pitchFamily="34" charset="-120"/>
+                <a:latin typeface="Libre Baskerville" pitchFamily="34" charset="0"/>
+                <a:ea typeface="Libre Baskerville" pitchFamily="34" charset="-122"/>
+                <a:cs typeface="Libre Baskerville" pitchFamily="34" charset="-120"/>
               </a:rPr>
               <a:t>40%</a:t>
             </a:r>
@@ -7331,9 +7331,9 @@
                 <a:solidFill>
                   <a:srgbClr val="DAFF94"/>
                 </a:solidFill>
-                <a:latin typeface="Cambria" pitchFamily="34" charset="0"/>
-                <a:ea typeface="Cambria" pitchFamily="34" charset="-122"/>
-                <a:cs typeface="Cambria" pitchFamily="34" charset="-120"/>
+                <a:latin typeface="Libre Baskerville" pitchFamily="34" charset="0"/>
+                <a:ea typeface="Libre Baskerville" pitchFamily="34" charset="-122"/>
+                <a:cs typeface="Libre Baskerville" pitchFamily="34" charset="-120"/>
               </a:rPr>
               <a:t>64%</a:t>
             </a:r>
@@ -7409,9 +7409,9 @@
                 <a:solidFill>
                   <a:srgbClr val="666666"/>
                 </a:solidFill>
-                <a:latin typeface="Courier New" pitchFamily="34" charset="0"/>
-                <a:ea typeface="Courier New" pitchFamily="34" charset="-122"/>
-                <a:cs typeface="Courier New" pitchFamily="34" charset="-120"/>
+                <a:latin typeface="JetBrains Mono" pitchFamily="34" charset="0"/>
+                <a:ea typeface="JetBrains Mono" pitchFamily="34" charset="-122"/>
+                <a:cs typeface="JetBrains Mono" pitchFamily="34" charset="-120"/>
               </a:rPr>
               <a:t>fonte: Sales Force, Opinion Box, Estadão — .report agosto_26</a:t>
             </a:r>
@@ -7480,9 +7480,9 @@
                 <a:solidFill>
                   <a:srgbClr val="000000"/>
                 </a:solidFill>
-                <a:latin typeface="Courier New" pitchFamily="34" charset="0"/>
-                <a:ea typeface="Courier New" pitchFamily="34" charset="-122"/>
-                <a:cs typeface="Courier New" pitchFamily="34" charset="-120"/>
+                <a:latin typeface="JetBrains Mono" pitchFamily="34" charset="0"/>
+                <a:ea typeface="JetBrains Mono" pitchFamily="34" charset="-122"/>
+                <a:cs typeface="JetBrains Mono" pitchFamily="34" charset="-120"/>
               </a:rPr>
               <a:t>report↗</a:t>
             </a:r>
@@ -7519,9 +7519,9 @@
                 <a:solidFill>
                   <a:srgbClr val="000000"/>
                 </a:solidFill>
-                <a:latin typeface="Cambria" pitchFamily="34" charset="0"/>
-                <a:ea typeface="Cambria" pitchFamily="34" charset="-122"/>
-                <a:cs typeface="Cambria" pitchFamily="34" charset="-120"/>
+                <a:latin typeface="Libre Baskerville" pitchFamily="34" charset="0"/>
+                <a:ea typeface="Libre Baskerville" pitchFamily="34" charset="-122"/>
+                <a:cs typeface="Libre Baskerville" pitchFamily="34" charset="-120"/>
               </a:rPr>
               <a:t>arpejo</a:t>
             </a:r>
@@ -7558,9 +7558,9 @@
                 <a:solidFill>
                   <a:srgbClr val="000000"/>
                 </a:solidFill>
-                <a:latin typeface="Courier New" pitchFamily="34" charset="0"/>
-                <a:ea typeface="Courier New" pitchFamily="34" charset="-122"/>
-                <a:cs typeface="Courier New" pitchFamily="34" charset="-120"/>
+                <a:latin typeface="JetBrains Mono" pitchFamily="34" charset="0"/>
+                <a:ea typeface="JetBrains Mono" pitchFamily="34" charset="-122"/>
+                <a:cs typeface="JetBrains Mono" pitchFamily="34" charset="-120"/>
               </a:rPr>
               <a:t>agosto_26</a:t>
             </a:r>
@@ -7619,9 +7619,9 @@
                 <a:solidFill>
                   <a:srgbClr val="000000"/>
                 </a:solidFill>
-                <a:latin typeface="Cambria" pitchFamily="34" charset="0"/>
-                <a:ea typeface="Cambria" pitchFamily="34" charset="-122"/>
-                <a:cs typeface="Cambria" pitchFamily="34" charset="-120"/>
+                <a:latin typeface="Libre Baskerville" pitchFamily="34" charset="0"/>
+                <a:ea typeface="Libre Baskerville" pitchFamily="34" charset="-122"/>
+                <a:cs typeface="Libre Baskerville" pitchFamily="34" charset="-120"/>
               </a:rPr>
               <a:t>IA</a:t>
             </a:r>
@@ -7781,9 +7781,9 @@
                 <a:solidFill>
                   <a:srgbClr val="DAFF94"/>
                 </a:solidFill>
-                <a:latin typeface="Cambria" pitchFamily="34" charset="0"/>
-                <a:ea typeface="Cambria" pitchFamily="34" charset="-122"/>
-                <a:cs typeface="Cambria" pitchFamily="34" charset="-120"/>
+                <a:latin typeface="Libre Baskerville" pitchFamily="34" charset="0"/>
+                <a:ea typeface="Libre Baskerville" pitchFamily="34" charset="-122"/>
+                <a:cs typeface="Libre Baskerville" pitchFamily="34" charset="-120"/>
               </a:rPr>
               <a:t>O que isso significa</a:t>
             </a:r>
@@ -7798,9 +7798,9 @@
                 <a:solidFill>
                   <a:srgbClr val="DAFF94"/>
                 </a:solidFill>
-                <a:latin typeface="Cambria" pitchFamily="34" charset="0"/>
-                <a:ea typeface="Cambria" pitchFamily="34" charset="-122"/>
-                <a:cs typeface="Cambria" pitchFamily="34" charset="-120"/>
+                <a:latin typeface="Libre Baskerville" pitchFamily="34" charset="0"/>
+                <a:ea typeface="Libre Baskerville" pitchFamily="34" charset="-122"/>
+                <a:cs typeface="Libre Baskerville" pitchFamily="34" charset="-120"/>
               </a:rPr>
               <a:t>pra sua marca:</a:t>
             </a:r>
@@ -7947,9 +7947,9 @@
                 <a:solidFill>
                   <a:srgbClr val="DAFF94"/>
                 </a:solidFill>
-                <a:latin typeface="Courier New" pitchFamily="34" charset="0"/>
-                <a:ea typeface="Courier New" pitchFamily="34" charset="-122"/>
-                <a:cs typeface="Courier New" pitchFamily="34" charset="-120"/>
+                <a:latin typeface="JetBrains Mono" pitchFamily="34" charset="0"/>
+                <a:ea typeface="JetBrains Mono" pitchFamily="34" charset="-122"/>
+                <a:cs typeface="JetBrains Mono" pitchFamily="34" charset="-120"/>
               </a:rPr>
               <a:t>report↗</a:t>
             </a:r>
@@ -7986,9 +7986,9 @@
                 <a:solidFill>
                   <a:srgbClr val="DAFF94"/>
                 </a:solidFill>
-                <a:latin typeface="Cambria" pitchFamily="34" charset="0"/>
-                <a:ea typeface="Cambria" pitchFamily="34" charset="-122"/>
-                <a:cs typeface="Cambria" pitchFamily="34" charset="-120"/>
+                <a:latin typeface="Libre Baskerville" pitchFamily="34" charset="0"/>
+                <a:ea typeface="Libre Baskerville" pitchFamily="34" charset="-122"/>
+                <a:cs typeface="Libre Baskerville" pitchFamily="34" charset="-120"/>
               </a:rPr>
               <a:t>arpejo</a:t>
             </a:r>
@@ -8025,9 +8025,9 @@
                 <a:solidFill>
                   <a:srgbClr val="DAFF94"/>
                 </a:solidFill>
-                <a:latin typeface="Courier New" pitchFamily="34" charset="0"/>
-                <a:ea typeface="Courier New" pitchFamily="34" charset="-122"/>
-                <a:cs typeface="Courier New" pitchFamily="34" charset="-120"/>
+                <a:latin typeface="JetBrains Mono" pitchFamily="34" charset="0"/>
+                <a:ea typeface="JetBrains Mono" pitchFamily="34" charset="-122"/>
+                <a:cs typeface="JetBrains Mono" pitchFamily="34" charset="-120"/>
               </a:rPr>
               <a:t>agosto_26</a:t>
             </a:r>
@@ -8086,9 +8086,9 @@
                 <a:solidFill>
                   <a:srgbClr val="000000"/>
                 </a:solidFill>
-                <a:latin typeface="Cambria" pitchFamily="34" charset="0"/>
-                <a:ea typeface="Cambria" pitchFamily="34" charset="-122"/>
-                <a:cs typeface="Cambria" pitchFamily="34" charset="-120"/>
+                <a:latin typeface="Libre Baskerville" pitchFamily="34" charset="0"/>
+                <a:ea typeface="Libre Baskerville" pitchFamily="34" charset="-122"/>
+                <a:cs typeface="Libre Baskerville" pitchFamily="34" charset="-120"/>
               </a:rPr>
               <a:t>HIPER-</a:t>
             </a:r>
@@ -8103,9 +8103,9 @@
                 <a:solidFill>
                   <a:srgbClr val="000000"/>
                 </a:solidFill>
-                <a:latin typeface="Cambria" pitchFamily="34" charset="0"/>
-                <a:ea typeface="Cambria" pitchFamily="34" charset="-122"/>
-                <a:cs typeface="Cambria" pitchFamily="34" charset="-120"/>
+                <a:latin typeface="Libre Baskerville" pitchFamily="34" charset="0"/>
+                <a:ea typeface="Libre Baskerville" pitchFamily="34" charset="-122"/>
+                <a:cs typeface="Libre Baskerville" pitchFamily="34" charset="-120"/>
               </a:rPr>
               <a:t>REALIDADE</a:t>
             </a:r>
@@ -8142,9 +8142,9 @@
                 <a:solidFill>
                   <a:srgbClr val="222222"/>
                 </a:solidFill>
-                <a:latin typeface="Cambria" pitchFamily="34" charset="0"/>
-                <a:ea typeface="Cambria" pitchFamily="34" charset="-122"/>
-                <a:cs typeface="Cambria" pitchFamily="34" charset="-120"/>
+                <a:latin typeface="Libre Baskerville" pitchFamily="34" charset="0"/>
+                <a:ea typeface="Libre Baskerville" pitchFamily="34" charset="-122"/>
+                <a:cs typeface="Libre Baskerville" pitchFamily="34" charset="-120"/>
               </a:rPr>
               <a:t>Na hiper-realidade, online ou offline, o que conta é a experiência.</a:t>
             </a:r>
@@ -8369,9 +8369,9 @@
                 <a:solidFill>
                   <a:srgbClr val="DAFF94"/>
                 </a:solidFill>
-                <a:latin typeface="Courier New" pitchFamily="34" charset="0"/>
-                <a:ea typeface="Courier New" pitchFamily="34" charset="-122"/>
-                <a:cs typeface="Courier New" pitchFamily="34" charset="-120"/>
+                <a:latin typeface="JetBrains Mono" pitchFamily="34" charset="0"/>
+                <a:ea typeface="JetBrains Mono" pitchFamily="34" charset="-122"/>
+                <a:cs typeface="JetBrains Mono" pitchFamily="34" charset="-120"/>
               </a:rPr>
               <a:t>QUEM SOMOS</a:t>
             </a:r>
@@ -8408,9 +8408,9 @@
                 <a:solidFill>
                   <a:srgbClr val="DAFF94"/>
                 </a:solidFill>
-                <a:latin typeface="Cambria" pitchFamily="34" charset="0"/>
-                <a:ea typeface="Cambria" pitchFamily="34" charset="-122"/>
-                <a:cs typeface="Cambria" pitchFamily="34" charset="-120"/>
+                <a:latin typeface="Libre Baskerville" pitchFamily="34" charset="0"/>
+                <a:ea typeface="Libre Baskerville" pitchFamily="34" charset="-122"/>
+                <a:cs typeface="Libre Baskerville" pitchFamily="34" charset="-120"/>
               </a:rPr>
               <a:t>[ Adicionar aqui o posicionamento oficial da Arpejo — quem</a:t>
             </a:r>
@@ -8425,9 +8425,9 @@
                 <a:solidFill>
                   <a:srgbClr val="DAFF94"/>
                 </a:solidFill>
-                <a:latin typeface="Cambria" pitchFamily="34" charset="0"/>
-                <a:ea typeface="Cambria" pitchFamily="34" charset="-122"/>
-                <a:cs typeface="Cambria" pitchFamily="34" charset="-120"/>
+                <a:latin typeface="Libre Baskerville" pitchFamily="34" charset="0"/>
+                <a:ea typeface="Libre Baskerville" pitchFamily="34" charset="-122"/>
+                <a:cs typeface="Libre Baskerville" pitchFamily="34" charset="-120"/>
               </a:rPr>
               <a:t>vocês são, para quem trabalham e o que os diferencia. ]</a:t>
             </a:r>
@@ -8535,9 +8535,9 @@
                 <a:solidFill>
                   <a:srgbClr val="DAFF94"/>
                 </a:solidFill>
-                <a:latin typeface="Courier New" pitchFamily="34" charset="0"/>
-                <a:ea typeface="Courier New" pitchFamily="34" charset="-122"/>
-                <a:cs typeface="Courier New" pitchFamily="34" charset="-120"/>
+                <a:latin typeface="JetBrains Mono" pitchFamily="34" charset="0"/>
+                <a:ea typeface="JetBrains Mono" pitchFamily="34" charset="-122"/>
+                <a:cs typeface="JetBrains Mono" pitchFamily="34" charset="-120"/>
               </a:rPr>
               <a:t>O QUE FAZEMOS</a:t>
             </a:r>
@@ -11249,9 +11249,9 @@
                 <a:solidFill>
                   <a:srgbClr val="DAFF94"/>
                 </a:solidFill>
-                <a:latin typeface="Courier New" pitchFamily="34" charset="0"/>
-                <a:ea typeface="Courier New" pitchFamily="34" charset="-122"/>
-                <a:cs typeface="Courier New" pitchFamily="34" charset="-120"/>
+                <a:latin typeface="JetBrains Mono" pitchFamily="34" charset="0"/>
+                <a:ea typeface="JetBrains Mono" pitchFamily="34" charset="-122"/>
+                <a:cs typeface="JetBrains Mono" pitchFamily="34" charset="-120"/>
               </a:rPr>
               <a:t>PROVA — O QUE FIZEMOS ESSE MÊS</a:t>
             </a:r>
@@ -11310,9 +11310,9 @@
                 <a:solidFill>
                   <a:srgbClr val="FFFFFF"/>
                 </a:solidFill>
-                <a:latin typeface="Cambria" pitchFamily="34" charset="0"/>
-                <a:ea typeface="Cambria" pitchFamily="34" charset="-122"/>
-                <a:cs typeface="Cambria" pitchFamily="34" charset="-120"/>
+                <a:latin typeface="Libre Baskerville" pitchFamily="34" charset="0"/>
+                <a:ea typeface="Libre Baskerville" pitchFamily="34" charset="-122"/>
+                <a:cs typeface="Libre Baskerville" pitchFamily="34" charset="-120"/>
               </a:rPr>
               <a:t>PagueVeloz — Dia dos Pais</a:t>
             </a:r>
@@ -11371,9 +11371,9 @@
                 <a:solidFill>
                   <a:srgbClr val="DAFF94"/>
                 </a:solidFill>
-                <a:latin typeface="Cambria" pitchFamily="34" charset="0"/>
-                <a:ea typeface="Cambria" pitchFamily="34" charset="-122"/>
-                <a:cs typeface="Cambria" pitchFamily="34" charset="-120"/>
+                <a:latin typeface="Libre Baskerville" pitchFamily="34" charset="0"/>
+                <a:ea typeface="Libre Baskerville" pitchFamily="34" charset="-122"/>
+                <a:cs typeface="Libre Baskerville" pitchFamily="34" charset="-120"/>
               </a:rPr>
               <a:t>Grupo Equatorial — Dia dos Pais</a:t>
             </a:r>
@@ -11410,9 +11410,9 @@
                 <a:solidFill>
                   <a:srgbClr val="999999"/>
                 </a:solidFill>
-                <a:latin typeface="Courier New" pitchFamily="34" charset="0"/>
-                <a:ea typeface="Courier New" pitchFamily="34" charset="-122"/>
-                <a:cs typeface="Courier New" pitchFamily="34" charset="-120"/>
+                <a:latin typeface="JetBrains Mono" pitchFamily="34" charset="0"/>
+                <a:ea typeface="JetBrains Mono" pitchFamily="34" charset="-122"/>
+                <a:cs typeface="JetBrains Mono" pitchFamily="34" charset="-120"/>
               </a:rPr>
               <a:t>Campanhas de Dia dos Pais assinadas pela Arpejo em agosto/26.</a:t>
             </a:r>
@@ -11481,9 +11481,9 @@
                 <a:solidFill>
                   <a:srgbClr val="000000"/>
                 </a:solidFill>
-                <a:latin typeface="Courier New" pitchFamily="34" charset="0"/>
-                <a:ea typeface="Courier New" pitchFamily="34" charset="-122"/>
-                <a:cs typeface="Courier New" pitchFamily="34" charset="-120"/>
+                <a:latin typeface="JetBrains Mono" pitchFamily="34" charset="0"/>
+                <a:ea typeface="JetBrains Mono" pitchFamily="34" charset="-122"/>
+                <a:cs typeface="JetBrains Mono" pitchFamily="34" charset="-120"/>
               </a:rPr>
               <a:t>report↗</a:t>
             </a:r>
@@ -11520,9 +11520,9 @@
                 <a:solidFill>
                   <a:srgbClr val="000000"/>
                 </a:solidFill>
-                <a:latin typeface="Cambria" pitchFamily="34" charset="0"/>
-                <a:ea typeface="Cambria" pitchFamily="34" charset="-122"/>
-                <a:cs typeface="Cambria" pitchFamily="34" charset="-120"/>
+                <a:latin typeface="Libre Baskerville" pitchFamily="34" charset="0"/>
+                <a:ea typeface="Libre Baskerville" pitchFamily="34" charset="-122"/>
+                <a:cs typeface="Libre Baskerville" pitchFamily="34" charset="-120"/>
               </a:rPr>
               <a:t>arpejo</a:t>
             </a:r>
@@ -11559,9 +11559,9 @@
                 <a:solidFill>
                   <a:srgbClr val="000000"/>
                 </a:solidFill>
-                <a:latin typeface="Courier New" pitchFamily="34" charset="0"/>
-                <a:ea typeface="Courier New" pitchFamily="34" charset="-122"/>
-                <a:cs typeface="Courier New" pitchFamily="34" charset="-120"/>
+                <a:latin typeface="JetBrains Mono" pitchFamily="34" charset="0"/>
+                <a:ea typeface="JetBrains Mono" pitchFamily="34" charset="-122"/>
+                <a:cs typeface="JetBrains Mono" pitchFamily="34" charset="-120"/>
               </a:rPr>
               <a:t>agosto_26</a:t>
             </a:r>
@@ -11598,9 +11598,9 @@
                 <a:solidFill>
                   <a:srgbClr val="000000"/>
                 </a:solidFill>
-                <a:latin typeface="Cambria" pitchFamily="34" charset="0"/>
-                <a:ea typeface="Cambria" pitchFamily="34" charset="-122"/>
-                <a:cs typeface="Cambria" pitchFamily="34" charset="-120"/>
+                <a:latin typeface="Libre Baskerville" pitchFamily="34" charset="0"/>
+                <a:ea typeface="Libre Baskerville" pitchFamily="34" charset="-122"/>
+                <a:cs typeface="Libre Baskerville" pitchFamily="34" charset="-120"/>
               </a:rPr>
               <a:t>O nosso diferencial: inteligência de mercado, todo mês.</a:t>
             </a:r>
@@ -11770,9 +11770,9 @@
                 <a:solidFill>
                   <a:srgbClr val="DAFF94"/>
                 </a:solidFill>
-                <a:latin typeface="Courier New" pitchFamily="34" charset="0"/>
-                <a:ea typeface="Courier New" pitchFamily="34" charset="-122"/>
-                <a:cs typeface="Courier New" pitchFamily="34" charset="-120"/>
+                <a:latin typeface="JetBrains Mono" pitchFamily="34" charset="0"/>
+                <a:ea typeface="JetBrains Mono" pitchFamily="34" charset="-122"/>
+                <a:cs typeface="JetBrains Mono" pitchFamily="34" charset="-120"/>
               </a:rPr>
               <a:t>COMO TRABALHAMOS</a:t>
             </a:r>
@@ -11836,9 +11836,9 @@
                 <a:solidFill>
                   <a:srgbClr val="DAFF94"/>
                 </a:solidFill>
-                <a:latin typeface="Courier New" pitchFamily="34" charset="0"/>
-                <a:ea typeface="Courier New" pitchFamily="34" charset="-122"/>
-                <a:cs typeface="Courier New" pitchFamily="34" charset="-120"/>
+                <a:latin typeface="JetBrains Mono" pitchFamily="34" charset="0"/>
+                <a:ea typeface="JetBrains Mono" pitchFamily="34" charset="-122"/>
+                <a:cs typeface="JetBrains Mono" pitchFamily="34" charset="-120"/>
               </a:rPr>
               <a:t>01</a:t>
             </a:r>
@@ -11941,9 +11941,9 @@
                 <a:solidFill>
                   <a:srgbClr val="DAFF94"/>
                 </a:solidFill>
-                <a:latin typeface="Courier New" pitchFamily="34" charset="0"/>
-                <a:ea typeface="Courier New" pitchFamily="34" charset="-122"/>
-                <a:cs typeface="Courier New" pitchFamily="34" charset="-120"/>
+                <a:latin typeface="JetBrains Mono" pitchFamily="34" charset="0"/>
+                <a:ea typeface="JetBrains Mono" pitchFamily="34" charset="-122"/>
+                <a:cs typeface="JetBrains Mono" pitchFamily="34" charset="-120"/>
               </a:rPr>
               <a:t>02</a:t>
             </a:r>
@@ -12046,9 +12046,9 @@
                 <a:solidFill>
                   <a:srgbClr val="DAFF94"/>
                 </a:solidFill>
-                <a:latin typeface="Courier New" pitchFamily="34" charset="0"/>
-                <a:ea typeface="Courier New" pitchFamily="34" charset="-122"/>
-                <a:cs typeface="Courier New" pitchFamily="34" charset="-120"/>
+                <a:latin typeface="JetBrains Mono" pitchFamily="34" charset="0"/>
+                <a:ea typeface="JetBrains Mono" pitchFamily="34" charset="-122"/>
+                <a:cs typeface="JetBrains Mono" pitchFamily="34" charset="-120"/>
               </a:rPr>
               <a:t>03</a:t>
             </a:r>
@@ -12151,9 +12151,9 @@
                 <a:solidFill>
                   <a:srgbClr val="DAFF94"/>
                 </a:solidFill>
-                <a:latin typeface="Courier New" pitchFamily="34" charset="0"/>
-                <a:ea typeface="Courier New" pitchFamily="34" charset="-122"/>
-                <a:cs typeface="Courier New" pitchFamily="34" charset="-120"/>
+                <a:latin typeface="JetBrains Mono" pitchFamily="34" charset="0"/>
+                <a:ea typeface="JetBrains Mono" pitchFamily="34" charset="-122"/>
+                <a:cs typeface="JetBrains Mono" pitchFamily="34" charset="-120"/>
               </a:rPr>
               <a:t>04</a:t>
             </a:r>

</xml_diff>

<commit_message>
Embed the real brand fonts (byte-for-byte) into every generated deck
arpejo.report_1.pptx (the actual report master, re-shared by Bianca)
turned out to already carry the four brand font families fully embedded
as PowerPoint font parts (Libre Baskerville, Urbanist, JetBrains Mono
Medium, Ubuntu Mono - Regular/Bold/Italic/BoldItalic each). Copied those
.fntdata parts into brand-guidelines/assets/fonts/embed/ and added
embed_fonts.py, which wires them into any pptxgenjs-built deck's
[Content_Types].xml/rels/presentation.xml the same way the source file
does - no font-obfuscation-format knowledge needed, just faithful
part-copying.

All three agosto_26 deliverables now carry these fonts embedded, so they
render correctly on any machine without Bianca needing to install fonts
or toggle "embed fonts in file" herself.

Co-Authored-By: Claude Sonnet 5 <noreply@anthropic.com>
Claude-Session: https://claude.ai/code/session_011ESx8gvmPcKzkkbhXuy6a7
</commit_message>
<xml_diff>
--- a/entregas-agosto26/apresentacao-prospeccao-agosto26.pptx
+++ b/entregas-agosto26/apresentacao-prospeccao-agosto26.pptx
@@ -1,6 +1,6 @@
 
 <file path=ppt/presentation.xml><?xml version="1.0" encoding="utf-8"?>
-<p:presentation xmlns:a="http://schemas.openxmlformats.org/drawingml/2006/main" xmlns:r="http://schemas.openxmlformats.org/officeDocument/2006/relationships" xmlns:p="http://schemas.openxmlformats.org/presentationml/2006/main" saveSubsetFonts="1" autoCompressPictures="0">
+<p:presentation xmlns:a="http://schemas.openxmlformats.org/drawingml/2006/main" xmlns:r="http://schemas.openxmlformats.org/officeDocument/2006/relationships" xmlns:p="http://schemas.openxmlformats.org/presentationml/2006/main" embedTrueTypeFonts="1" saveSubsetFonts="1" autoCompressPictures="0">
   <p:sldMasterIdLst>
     <p:sldMasterId id="2147483648" r:id="rId1"/>
   </p:sldMasterIdLst>
@@ -21,6 +21,36 @@
   </p:notesMasterIdLst>
   <p:sldSz cx="12192000" cy="6858000"/>
   <p:notesSz cx="6858000" cy="12192000"/>
+  <p:embeddedFontLst>
+    <p:embeddedFont>
+      <p:font typeface="JetBrains Mono Medium"/>
+      <p:regular r:id="rId17"/>
+      <p:bold r:id="rId18"/>
+      <p:italic r:id="rId19"/>
+      <p:boldItalic r:id="rId20"/>
+    </p:embeddedFont>
+    <p:embeddedFont>
+      <p:font typeface="Urbanist"/>
+      <p:regular r:id="rId21"/>
+      <p:bold r:id="rId22"/>
+      <p:italic r:id="rId23"/>
+      <p:boldItalic r:id="rId24"/>
+    </p:embeddedFont>
+    <p:embeddedFont>
+      <p:font typeface="Libre Baskerville"/>
+      <p:regular r:id="rId25"/>
+      <p:bold r:id="rId26"/>
+      <p:italic r:id="rId27"/>
+      <p:boldItalic r:id="rId28"/>
+    </p:embeddedFont>
+    <p:embeddedFont>
+      <p:font typeface="Ubuntu Mono"/>
+      <p:regular r:id="rId29"/>
+      <p:bold r:id="rId30"/>
+      <p:italic r:id="rId31"/>
+      <p:boldItalic r:id="rId32"/>
+    </p:embeddedFont>
+  </p:embeddedFontLst>
   <p:defaultTextStyle>
     <a:lvl1pPr marL="0" algn="l" defTabSz="914400" rtl="0" eaLnBrk="1" latinLnBrk="0" hangingPunct="1">
       <a:defRPr sz="1800" kern="1200">

</xml_diff>

<commit_message>
Add real @arpejo case descriptions and video links to prospecting + client decks
Pulled the actual campaign concepts for PagueVeloz ("O nome por trás do
meu nome") and Grupo Equatorial ("Espelho") from the fuller agosto_26
report PDF Bianca re-shared, replacing the bare campaign-name badges.
Each case now links to its case video on YouTube (can't embed the video
file itself - no network access to download it in this environment - but
a clickable hyperlink works in both PowerPoint and when exported).

Co-Authored-By: Claude Sonnet 5 <noreply@anthropic.com>
Claude-Session: https://claude.ai/code/session_011ESx8gvmPcKzkkbhXuy6a7
</commit_message>
<xml_diff>
--- a/entregas-agosto26/apresentacao-prospeccao-agosto26.pptx
+++ b/entregas-agosto26/apresentacao-prospeccao-agosto26.pptx
@@ -4223,8 +4223,8 @@
         </p:nvSpPr>
         <p:spPr>
           <a:xfrm>
-            <a:off x="1097280" y="2377440"/>
-            <a:ext cx="4572000" cy="822960"/>
+            <a:off x="548640" y="1280160"/>
+            <a:ext cx="5364328" cy="731520"/>
           </a:xfrm>
           <a:prstGeom prst="ellipse">
             <a:avLst/>
@@ -4245,8 +4245,8 @@
         </p:nvSpPr>
         <p:spPr>
           <a:xfrm>
-            <a:off x="1097280" y="2377440"/>
-            <a:ext cx="4572000" cy="822960"/>
+            <a:off x="548640" y="1280160"/>
+            <a:ext cx="5364328" cy="731520"/>
           </a:xfrm>
           <a:prstGeom prst="rect">
             <a:avLst/>
@@ -4262,7 +4262,7 @@
               <a:buNone/>
             </a:pPr>
             <a:r>
-              <a:rPr lang="en-US" sz="1600" i="1" dirty="0">
+              <a:rPr lang="en-US" sz="1500" i="1" dirty="0">
                 <a:solidFill>
                   <a:srgbClr val="FFFFFF"/>
                 </a:solidFill>
@@ -4272,7 +4272,7 @@
               </a:rPr>
               <a:t>PagueVeloz — Dia dos Pais</a:t>
             </a:r>
-            <a:endParaRPr lang="en-US" sz="1600" dirty="0"/>
+            <a:endParaRPr lang="en-US" sz="1500" dirty="0"/>
           </a:p>
         </p:txBody>
       </p:sp>
@@ -4292,8 +4292,8 @@
         </p:blipFill>
         <p:spPr>
           <a:xfrm>
-            <a:off x="5427330" y="2616098"/>
-            <a:ext cx="345643" cy="345643"/>
+            <a:off x="5697901" y="1492301"/>
+            <a:ext cx="307238" cy="307238"/>
           </a:xfrm>
           <a:prstGeom prst="rect">
             <a:avLst/>
@@ -4302,14 +4302,101 @@
       </p:pic>
       <p:sp>
         <p:nvSpPr>
-          <p:cNvPr id="7" name="Shape 3"/>
-          <p:cNvSpPr/>
-          <p:nvPr/>
-        </p:nvSpPr>
-        <p:spPr>
-          <a:xfrm>
-            <a:off x="6400800" y="3657600"/>
-            <a:ext cx="4754880" cy="822960"/>
+          <p:cNvPr id="7" name="Text 3"/>
+          <p:cNvSpPr/>
+          <p:nvPr/>
+        </p:nvSpPr>
+        <p:spPr>
+          <a:xfrm>
+            <a:off x="548640" y="2286000"/>
+            <a:ext cx="5364328" cy="2103120"/>
+          </a:xfrm>
+          <a:prstGeom prst="rect">
+            <a:avLst/>
+          </a:prstGeom>
+          <a:noFill/>
+          <a:ln/>
+        </p:spPr>
+        <p:txBody>
+          <a:bodyPr wrap="square" lIns="0" tIns="0" rIns="0" bIns="0" rtlCol="0" anchor="ctr"/>
+          <a:lstStyle/>
+          <a:p>
+            <a:pPr indent="0" marL="0">
+              <a:buNone/>
+            </a:pPr>
+            <a:r>
+              <a:rPr lang="en-US" sz="1250" dirty="0">
+                <a:solidFill>
+                  <a:srgbClr val="FFFFFF"/>
+                </a:solidFill>
+                <a:latin typeface="Arial" pitchFamily="34" charset="0"/>
+                <a:ea typeface="Arial" pitchFamily="34" charset="-122"/>
+                <a:cs typeface="Arial" pitchFamily="34" charset="-120"/>
+              </a:rPr>
+              <a:t>“O nome por trás do meu nome”: transformamos fachadas de comércio em homenagens aos pais que apoiaram o sonho de três empreendedores em São Paulo e Campinas.</a:t>
+            </a:r>
+            <a:endParaRPr lang="en-US" sz="1250" dirty="0"/>
+          </a:p>
+        </p:txBody>
+      </p:sp>
+      <p:sp>
+        <p:nvSpPr>
+          <p:cNvPr id="8" name="Text 4">
+            <a:hlinkClick r:id="rId3" tooltip=""/>
+          </p:cNvPr>
+          <p:cNvSpPr/>
+          <p:nvPr/>
+        </p:nvSpPr>
+        <p:spPr>
+          <a:xfrm>
+            <a:off x="548640" y="4572000"/>
+            <a:ext cx="5364328" cy="365760"/>
+          </a:xfrm>
+          <a:prstGeom prst="rect">
+            <a:avLst/>
+          </a:prstGeom>
+          <a:noFill/>
+          <a:ln/>
+        </p:spPr>
+        <p:txBody>
+          <a:bodyPr wrap="square" lIns="0" tIns="0" rIns="0" bIns="0" rtlCol="0" anchor="ctr"/>
+          <a:lstStyle/>
+          <a:p>
+            <a:pPr indent="0" marL="0">
+              <a:buNone/>
+            </a:pPr>
+            <a:r>
+              <a:rPr lang="en-US" sz="1200" b="1" u="sng" dirty="0">
+                <a:solidFill>
+                  <a:srgbClr val="FFFFFF"/>
+                </a:solidFill>
+                <a:latin typeface="JetBrains Mono" pitchFamily="34" charset="0"/>
+                <a:ea typeface="JetBrains Mono" pitchFamily="34" charset="-122"/>
+                <a:cs typeface="JetBrains Mono" pitchFamily="34" charset="-120"/>
+                <a:hlinkClick r:id="rId3" invalidUrl="" action="" tgtFrame="" tooltip="" history="1" highlightClick="0" endSnd="0">
+                  <a:extLst>
+                    <a:ext uri="{A12FA001-AC4F-418D-AE19-62706E023703}">
+                      <ahyp:hlinkClr xmlns:ahyp="http://schemas.microsoft.com/office/drawing/2018/hyperlinkcolor" val="tx"/>
+                    </a:ext>
+                  </a:extLst>
+                </a:hlinkClick>
+              </a:rPr>
+              <a:t>▶ assistir ao case</a:t>
+            </a:r>
+            <a:endParaRPr lang="en-US" sz="1200" dirty="0"/>
+          </a:p>
+        </p:txBody>
+      </p:sp>
+      <p:sp>
+        <p:nvSpPr>
+          <p:cNvPr id="9" name="Shape 5"/>
+          <p:cNvSpPr/>
+          <p:nvPr/>
+        </p:nvSpPr>
+        <p:spPr>
+          <a:xfrm>
+            <a:off x="6278728" y="1280160"/>
+            <a:ext cx="5364328" cy="731520"/>
           </a:xfrm>
           <a:prstGeom prst="ellipse">
             <a:avLst/>
@@ -4324,14 +4411,14 @@
       </p:sp>
       <p:sp>
         <p:nvSpPr>
-          <p:cNvPr id="8" name="Text 4"/>
-          <p:cNvSpPr/>
-          <p:nvPr/>
-        </p:nvSpPr>
-        <p:spPr>
-          <a:xfrm>
-            <a:off x="6400800" y="3657600"/>
-            <a:ext cx="4754880" cy="822960"/>
+          <p:cNvPr id="10" name="Text 6"/>
+          <p:cNvSpPr/>
+          <p:nvPr/>
+        </p:nvSpPr>
+        <p:spPr>
+          <a:xfrm>
+            <a:off x="6278728" y="1280160"/>
+            <a:ext cx="5364328" cy="731520"/>
           </a:xfrm>
           <a:prstGeom prst="rect">
             <a:avLst/>
@@ -4347,7 +4434,7 @@
               <a:buNone/>
             </a:pPr>
             <a:r>
-              <a:rPr lang="en-US" sz="1600" i="1" dirty="0">
+              <a:rPr lang="en-US" sz="1500" i="1" dirty="0">
                 <a:solidFill>
                   <a:srgbClr val="DAFF94"/>
                 </a:solidFill>
@@ -4357,28 +4444,28 @@
               </a:rPr>
               <a:t>Grupo Equatorial — Dia dos Pais</a:t>
             </a:r>
-            <a:endParaRPr lang="en-US" sz="1600" dirty="0"/>
+            <a:endParaRPr lang="en-US" sz="1500" dirty="0"/>
           </a:p>
         </p:txBody>
       </p:sp>
       <p:pic>
         <p:nvPicPr>
-          <p:cNvPr id="9" name="Image 2" descr="/home/user/data-manipulation-exercises/.claude/skills/brand-guidelines/assets/textures/globe-lime.png">    </p:cNvPr>
+          <p:cNvPr id="11" name="Image 2" descr="/home/user/data-manipulation-exercises/.claude/skills/brand-guidelines/assets/textures/globe-lime.png">    </p:cNvPr>
           <p:cNvPicPr>
             <a:picLocks noChangeAspect="1"/>
           </p:cNvPicPr>
           <p:nvPr/>
         </p:nvPicPr>
         <p:blipFill>
-          <a:blip r:embed="rId3"/>
+          <a:blip r:embed="rId4"/>
           <a:stretch>
             <a:fillRect/>
           </a:stretch>
         </p:blipFill>
         <p:spPr>
           <a:xfrm>
-            <a:off x="10913730" y="3896258"/>
-            <a:ext cx="345643" cy="345643"/>
+            <a:off x="11427988" y="1492301"/>
+            <a:ext cx="307238" cy="307238"/>
           </a:xfrm>
           <a:prstGeom prst="rect">
             <a:avLst/>
@@ -4387,14 +4474,14 @@
       </p:pic>
       <p:sp>
         <p:nvSpPr>
-          <p:cNvPr id="10" name="Text 5"/>
-          <p:cNvSpPr/>
-          <p:nvPr/>
-        </p:nvSpPr>
-        <p:spPr>
-          <a:xfrm>
-            <a:off x="1097280" y="5120640"/>
-            <a:ext cx="9144000" cy="457200"/>
+          <p:cNvPr id="12" name="Text 7"/>
+          <p:cNvSpPr/>
+          <p:nvPr/>
+        </p:nvSpPr>
+        <p:spPr>
+          <a:xfrm>
+            <a:off x="6278728" y="2286000"/>
+            <a:ext cx="5364328" cy="2103120"/>
           </a:xfrm>
           <a:prstGeom prst="rect">
             <a:avLst/>
@@ -4410,17 +4497,104 @@
               <a:buNone/>
             </a:pPr>
             <a:r>
-              <a:rPr lang="en-US" sz="1200" dirty="0">
-                <a:solidFill>
-                  <a:srgbClr val="999999"/>
+              <a:rPr lang="en-US" sz="1250" dirty="0">
+                <a:solidFill>
+                  <a:srgbClr val="FFFFFF"/>
+                </a:solidFill>
+                <a:latin typeface="Arial" pitchFamily="34" charset="0"/>
+                <a:ea typeface="Arial" pitchFamily="34" charset="-122"/>
+                <a:cs typeface="Arial" pitchFamily="34" charset="-120"/>
+              </a:rPr>
+              <a:t>Espelhos apagados em locais de grande circulação só acendem uma palavra quando a pessoa termina de contar o que herdou do pai — não na aparência, na atitude.</a:t>
+            </a:r>
+            <a:endParaRPr lang="en-US" sz="1250" dirty="0"/>
+          </a:p>
+        </p:txBody>
+      </p:sp>
+      <p:sp>
+        <p:nvSpPr>
+          <p:cNvPr id="13" name="Text 8">
+            <a:hlinkClick r:id="rId5" tooltip=""/>
+          </p:cNvPr>
+          <p:cNvSpPr/>
+          <p:nvPr/>
+        </p:nvSpPr>
+        <p:spPr>
+          <a:xfrm>
+            <a:off x="6278728" y="4572000"/>
+            <a:ext cx="5364328" cy="365760"/>
+          </a:xfrm>
+          <a:prstGeom prst="rect">
+            <a:avLst/>
+          </a:prstGeom>
+          <a:noFill/>
+          <a:ln/>
+        </p:spPr>
+        <p:txBody>
+          <a:bodyPr wrap="square" lIns="0" tIns="0" rIns="0" bIns="0" rtlCol="0" anchor="ctr"/>
+          <a:lstStyle/>
+          <a:p>
+            <a:pPr indent="0" marL="0">
+              <a:buNone/>
+            </a:pPr>
+            <a:r>
+              <a:rPr lang="en-US" sz="1200" b="1" u="sng" dirty="0">
+                <a:solidFill>
+                  <a:srgbClr val="DAFF94"/>
                 </a:solidFill>
                 <a:latin typeface="JetBrains Mono" pitchFamily="34" charset="0"/>
                 <a:ea typeface="JetBrains Mono" pitchFamily="34" charset="-122"/>
                 <a:cs typeface="JetBrains Mono" pitchFamily="34" charset="-120"/>
+                <a:hlinkClick r:id="rId5" invalidUrl="" action="" tgtFrame="" tooltip="" history="1" highlightClick="0" endSnd="0">
+                  <a:extLst>
+                    <a:ext uri="{A12FA001-AC4F-418D-AE19-62706E023703}">
+                      <ahyp:hlinkClr xmlns:ahyp="http://schemas.microsoft.com/office/drawing/2018/hyperlinkcolor" val="tx"/>
+                    </a:ext>
+                  </a:extLst>
+                </a:hlinkClick>
+              </a:rPr>
+              <a:t>▶ assistir ao case</a:t>
+            </a:r>
+            <a:endParaRPr lang="en-US" sz="1200" dirty="0"/>
+          </a:p>
+        </p:txBody>
+      </p:sp>
+      <p:sp>
+        <p:nvSpPr>
+          <p:cNvPr id="14" name="Text 9"/>
+          <p:cNvSpPr/>
+          <p:nvPr/>
+        </p:nvSpPr>
+        <p:spPr>
+          <a:xfrm>
+            <a:off x="548640" y="5394960"/>
+            <a:ext cx="9144000" cy="457200"/>
+          </a:xfrm>
+          <a:prstGeom prst="rect">
+            <a:avLst/>
+          </a:prstGeom>
+          <a:noFill/>
+          <a:ln/>
+        </p:spPr>
+        <p:txBody>
+          <a:bodyPr wrap="square" lIns="0" tIns="0" rIns="0" bIns="0" rtlCol="0" anchor="ctr"/>
+          <a:lstStyle/>
+          <a:p>
+            <a:pPr indent="0" marL="0">
+              <a:buNone/>
+            </a:pPr>
+            <a:r>
+              <a:rPr lang="en-US" sz="1100" dirty="0">
+                <a:solidFill>
+                  <a:srgbClr val="999999"/>
+                </a:solidFill>
+                <a:latin typeface="JetBrains Mono" pitchFamily="34" charset="0"/>
+                <a:ea typeface="JetBrains Mono" pitchFamily="34" charset="-122"/>
+                <a:cs typeface="JetBrains Mono" pitchFamily="34" charset="-120"/>
               </a:rPr>
               <a:t>Campanhas de Dia dos Pais assinadas pela Arpejo em agosto/26.</a:t>
             </a:r>
-            <a:endParaRPr lang="en-US" sz="1200" dirty="0"/>
+            <a:endParaRPr lang="en-US" sz="1100" dirty="0"/>
           </a:p>
         </p:txBody>
       </p:sp>

</xml_diff>

<commit_message>
Add real photography to all three decks for four of the five trends
Bianca sent two of her own generic stock photos (home yoga, rooftop
toast) for Experiências Transformadoras and Geração Sem Ressaca, and
confirmed reusing the Loewe/F1-Charlotte Tilbury report stills for
Hiper-realidade and New-Wave Sport Fandom across all three pieces (not
just the client-only material as before).

Instagram carousel and prospecting deck's Hiper-realidade slide now use
full-bleed photo + dark scrim instead of flat color cards, matching the
client material's existing treatment. Only the Agentic Search/News card
stays flat-color (no sourced photo for it).

Co-Authored-By: Claude Sonnet 5 <noreply@anthropic.com>
Claude-Session: https://claude.ai/code/session_011ESx8gvmPcKzkkbhXuy6a7
</commit_message>
<xml_diff>
--- a/entregas-agosto26/apresentacao-prospeccao-agosto26.pptx
+++ b/entregas-agosto26/apresentacao-prospeccao-agosto26.pptx
@@ -3322,9 +3322,32 @@
           </a:p>
         </p:txBody>
       </p:sp>
-      <p:sp>
-        <p:nvSpPr>
-          <p:cNvPr id="5" name="Shape 3"/>
+      <p:pic>
+        <p:nvPicPr>
+          <p:cNvPr id="5" name="Image 0" descr="/tmp/claude-0/-home-user-data-manipulation-exercises/f19acac8-ccb4-5197-8e49-c3b6029ad477/scratchpad/report-images/final/prospect-hiper-realidade.jpg">    </p:cNvPr>
+          <p:cNvPicPr>
+            <a:picLocks noChangeAspect="1"/>
+          </p:cNvPicPr>
+          <p:nvPr/>
+        </p:nvPicPr>
+        <p:blipFill>
+          <a:blip r:embed="rId1"/>
+          <a:srcRect l="0" r="0" t="0" b="0"/>
+          <a:stretch/>
+        </p:blipFill>
+        <p:spPr>
+          <a:xfrm>
+            <a:off x="640080" y="1188720"/>
+            <a:ext cx="5120640" cy="4480560"/>
+          </a:xfrm>
+          <a:prstGeom prst="rect">
+            <a:avLst/>
+          </a:prstGeom>
+        </p:spPr>
+      </p:pic>
+      <p:sp>
+        <p:nvSpPr>
+          <p:cNvPr id="6" name="Shape 3"/>
           <p:cNvSpPr/>
           <p:nvPr/>
         </p:nvSpPr>
@@ -3338,22 +3361,46 @@
               <a:gd name="adj" fmla="val 3061"/>
             </a:avLst>
           </a:prstGeom>
+          <a:ln w="12700">
+            <a:solidFill>
+              <a:srgbClr val="DAFF94"/>
+            </a:solidFill>
+            <a:prstDash val="solid"/>
+          </a:ln>
+        </p:spPr>
+      </p:sp>
+      <p:sp>
+        <p:nvSpPr>
+          <p:cNvPr id="7" name="Shape 4"/>
+          <p:cNvSpPr/>
+          <p:nvPr/>
+        </p:nvSpPr>
+        <p:spPr>
+          <a:xfrm>
+            <a:off x="640080" y="3200400"/>
+            <a:ext cx="5120640" cy="2468880"/>
+          </a:xfrm>
+          <a:prstGeom prst="rect">
+            <a:avLst/>
+          </a:prstGeom>
           <a:solidFill>
-            <a:srgbClr val="DAFF94"/>
+            <a:srgbClr val="000000">
+              <a:alpha val="75000"/>
+            </a:srgbClr>
           </a:solidFill>
           <a:ln/>
         </p:spPr>
       </p:sp>
       <p:sp>
         <p:nvSpPr>
-          <p:cNvPr id="6" name="Text 4"/>
-          <p:cNvSpPr/>
-          <p:nvPr/>
-        </p:nvSpPr>
-        <p:spPr>
-          <a:xfrm>
-            <a:off x="914400" y="1463040"/>
-            <a:ext cx="4572000" cy="1463040"/>
+          <p:cNvPr id="8" name="Text 5"/>
+          <p:cNvSpPr/>
+          <p:nvPr/>
+        </p:nvSpPr>
+        <p:spPr>
+          <a:xfrm>
+            <a:off x="914400" y="3337560"/>
+            <a:ext cx="4572000" cy="1097280"/>
           </a:xfrm>
           <a:prstGeom prst="rect">
             <a:avLst/>
@@ -3369,9 +3416,9 @@
               <a:buNone/>
             </a:pPr>
             <a:r>
-              <a:rPr lang="en-US" sz="3000" b="1" i="1" dirty="0">
-                <a:solidFill>
-                  <a:srgbClr val="000000"/>
+              <a:rPr lang="en-US" sz="2600" b="1" i="1" dirty="0">
+                <a:solidFill>
+                  <a:srgbClr val="DAFF94"/>
                 </a:solidFill>
                 <a:latin typeface="Libre Baskerville" pitchFamily="34" charset="0"/>
                 <a:ea typeface="Libre Baskerville" pitchFamily="34" charset="-122"/>
@@ -3379,16 +3426,16 @@
               </a:rPr>
               <a:t>HIPER-</a:t>
             </a:r>
-            <a:endParaRPr lang="en-US" sz="3000" dirty="0"/>
+            <a:endParaRPr lang="en-US" sz="2600" dirty="0"/>
           </a:p>
           <a:p>
             <a:pPr indent="0" marL="0">
               <a:buNone/>
             </a:pPr>
             <a:r>
-              <a:rPr lang="en-US" sz="3000" b="1" i="1" dirty="0">
-                <a:solidFill>
-                  <a:srgbClr val="000000"/>
+              <a:rPr lang="en-US" sz="2600" b="1" i="1" dirty="0">
+                <a:solidFill>
+                  <a:srgbClr val="DAFF94"/>
                 </a:solidFill>
                 <a:latin typeface="Libre Baskerville" pitchFamily="34" charset="0"/>
                 <a:ea typeface="Libre Baskerville" pitchFamily="34" charset="-122"/>
@@ -3396,20 +3443,20 @@
               </a:rPr>
               <a:t>REALIDADE</a:t>
             </a:r>
-            <a:endParaRPr lang="en-US" sz="3000" dirty="0"/>
-          </a:p>
-        </p:txBody>
-      </p:sp>
-      <p:sp>
-        <p:nvSpPr>
-          <p:cNvPr id="7" name="Text 5"/>
-          <p:cNvSpPr/>
-          <p:nvPr/>
-        </p:nvSpPr>
-        <p:spPr>
-          <a:xfrm>
-            <a:off x="914400" y="3017520"/>
-            <a:ext cx="4572000" cy="1280160"/>
+            <a:endParaRPr lang="en-US" sz="2600" dirty="0"/>
+          </a:p>
+        </p:txBody>
+      </p:sp>
+      <p:sp>
+        <p:nvSpPr>
+          <p:cNvPr id="9" name="Text 6"/>
+          <p:cNvSpPr/>
+          <p:nvPr/>
+        </p:nvSpPr>
+        <p:spPr>
+          <a:xfrm>
+            <a:off x="914400" y="4434840"/>
+            <a:ext cx="4572000" cy="1097280"/>
           </a:xfrm>
           <a:prstGeom prst="rect">
             <a:avLst/>
@@ -3425,9 +3472,9 @@
               <a:buNone/>
             </a:pPr>
             <a:r>
-              <a:rPr lang="en-US" sz="1500" i="1" dirty="0">
-                <a:solidFill>
-                  <a:srgbClr val="222222"/>
+              <a:rPr lang="en-US" sz="1300" i="1" dirty="0">
+                <a:solidFill>
+                  <a:srgbClr val="FFFFFF"/>
                 </a:solidFill>
                 <a:latin typeface="Libre Baskerville" pitchFamily="34" charset="0"/>
                 <a:ea typeface="Libre Baskerville" pitchFamily="34" charset="-122"/>
@@ -3435,13 +3482,13 @@
               </a:rPr>
               <a:t>Na hiper-realidade, online ou offline, o que conta é a experiência.</a:t>
             </a:r>
-            <a:endParaRPr lang="en-US" sz="1500" dirty="0"/>
-          </a:p>
-        </p:txBody>
-      </p:sp>
-      <p:sp>
-        <p:nvSpPr>
-          <p:cNvPr id="8" name="Text 6"/>
+            <a:endParaRPr lang="en-US" sz="1300" dirty="0"/>
+          </a:p>
+        </p:txBody>
+      </p:sp>
+      <p:sp>
+        <p:nvSpPr>
+          <p:cNvPr id="10" name="Text 7"/>
           <p:cNvSpPr/>
           <p:nvPr/>
         </p:nvSpPr>
@@ -3480,7 +3527,7 @@
       </p:sp>
       <p:sp>
         <p:nvSpPr>
-          <p:cNvPr id="9" name="Text 7"/>
+          <p:cNvPr id="11" name="Text 8"/>
           <p:cNvSpPr/>
           <p:nvPr/>
         </p:nvSpPr>
@@ -3519,7 +3566,7 @@
       </p:sp>
       <p:sp>
         <p:nvSpPr>
-          <p:cNvPr id="10" name="Text 8"/>
+          <p:cNvPr id="12" name="Text 9"/>
           <p:cNvSpPr/>
           <p:nvPr/>
         </p:nvSpPr>
@@ -3558,14 +3605,14 @@
       </p:sp>
       <p:pic>
         <p:nvPicPr>
-          <p:cNvPr id="11" name="Image 0" descr="/home/user/data-manipulation-exercises/.claude/skills/brand-guidelines/assets/textures/arrow-lime.png">    </p:cNvPr>
+          <p:cNvPr id="13" name="Image 1" descr="/home/user/data-manipulation-exercises/.claude/skills/brand-guidelines/assets/textures/arrow-lime.png">    </p:cNvPr>
           <p:cNvPicPr>
             <a:picLocks noChangeAspect="1"/>
           </p:cNvPicPr>
           <p:nvPr/>
         </p:nvPicPr>
         <p:blipFill>
-          <a:blip r:embed="rId1"/>
+          <a:blip r:embed="rId2"/>
           <a:stretch>
             <a:fillRect/>
           </a:stretch>

</xml_diff>

<commit_message>
Adiciona foto ao slide "O nosso diferencial" da prospecção
Reaproveita o mesmo painel preto arredondado dos cards de tendência
(texto + foto em colunas) para o slide institucional do .report como
diferencial, mantendo a identidade visual consistente com o resto da peça.
</commit_message>
<xml_diff>
--- a/entregas-agosto26/apresentacao-prospeccao-agosto26.pptx
+++ b/entregas-agosto26/apresentacao-prospeccao-agosto26.pptx
@@ -3090,7 +3090,7 @@
       </p:sp>
       <p:pic>
         <p:nvPicPr>
-          <p:cNvPr id="42" name="Image 0" descr="/home/user/data-manipulation-exercises/.claude/skills/brand-guidelines/assets/textures/globe-black.png">    </p:cNvPr>
+          <p:cNvPr id="42" name="Image 0" descr="/tmp/claude-0/-home-user-data-manipulation-exercises/f19acac8-ccb4-5197-8e49-c3b6029ad477/scratchpad/texture-check/assets/globe-black.png">    </p:cNvPr>
           <p:cNvPicPr>
             <a:picLocks noChangeAspect="1"/>
           </p:cNvPicPr>
@@ -3114,7 +3114,7 @@
       </p:pic>
       <p:pic>
         <p:nvPicPr>
-          <p:cNvPr id="43" name="Image 1" descr="/home/user/data-manipulation-exercises/.claude/skills/arpejo-report-desdobramento/assets/arpejo-report-logo-all-black.png">    </p:cNvPr>
+          <p:cNvPr id="43" name="Image 1" descr="../assets/arpejo-report-logo-all-black.png">    </p:cNvPr>
           <p:cNvPicPr>
             <a:picLocks noChangeAspect="1"/>
           </p:cNvPicPr>
@@ -3177,7 +3177,7 @@
       </p:sp>
       <p:pic>
         <p:nvPicPr>
-          <p:cNvPr id="45" name="Image 2" descr="/home/user/data-manipulation-exercises/.claude/skills/brand-guidelines/assets/textures/arrow-black.png">    </p:cNvPr>
+          <p:cNvPr id="45" name="Image 2" descr="/tmp/claude-0/-home-user-data-manipulation-exercises/f19acac8-ccb4-5197-8e49-c3b6029ad477/scratchpad/texture-check/assets/arrow-black.png">    </p:cNvPr>
           <p:cNvPicPr>
             <a:picLocks noChangeAspect="1"/>
           </p:cNvPicPr>
@@ -3948,7 +3948,7 @@
       </p:sp>
       <p:pic>
         <p:nvPicPr>
-          <p:cNvPr id="8" name="Image 0" descr="/home/user/data-manipulation-exercises/.claude/skills/brand-guidelines/assets/textures/globe-black.png">    </p:cNvPr>
+          <p:cNvPr id="8" name="Image 0" descr="/tmp/claude-0/-home-user-data-manipulation-exercises/f19acac8-ccb4-5197-8e49-c3b6029ad477/scratchpad/texture-check/assets/globe-black.png">    </p:cNvPr>
           <p:cNvPicPr>
             <a:picLocks noChangeAspect="1"/>
           </p:cNvPicPr>
@@ -4523,7 +4523,7 @@
       </p:sp>
       <p:pic>
         <p:nvPicPr>
-          <p:cNvPr id="8" name="Image 0" descr="/home/user/data-manipulation-exercises/.claude/skills/brand-guidelines/assets/textures/globe-lime.png">    </p:cNvPr>
+          <p:cNvPr id="8" name="Image 0" descr="/tmp/claude-0/-home-user-data-manipulation-exercises/f19acac8-ccb4-5197-8e49-c3b6029ad477/scratchpad/texture-check/assets/globe-lime.png">    </p:cNvPr>
           <p:cNvPicPr>
             <a:picLocks noChangeAspect="1"/>
           </p:cNvPicPr>
@@ -8800,7 +8800,7 @@
       </p:grpSpPr>
       <p:pic>
         <p:nvPicPr>
-          <p:cNvPr id="2" name="Image 0" descr="/home/user/data-manipulation-exercises/.claude/skills/brand-guidelines/assets/textures/globe-black.png">    </p:cNvPr>
+          <p:cNvPr id="2" name="Image 0" descr="/tmp/claude-0/-home-user-data-manipulation-exercises/f19acac8-ccb4-5197-8e49-c3b6029ad477/scratchpad/texture-check/assets/globe-black.png">    </p:cNvPr>
           <p:cNvPicPr>
             <a:picLocks noChangeAspect="1"/>
           </p:cNvPicPr>
@@ -8863,32 +8863,54 @@
       </p:sp>
       <p:sp>
         <p:nvSpPr>
-          <p:cNvPr id="4" name="Text 1"/>
-          <p:cNvSpPr/>
-          <p:nvPr/>
-        </p:nvSpPr>
-        <p:spPr>
-          <a:xfrm>
-            <a:off x="548640" y="1371600"/>
-            <a:ext cx="11094415" cy="1097280"/>
-          </a:xfrm>
-          <a:prstGeom prst="rect">
-            <a:avLst/>
-          </a:prstGeom>
-          <a:noFill/>
-          <a:ln/>
-        </p:spPr>
-        <p:txBody>
-          <a:bodyPr wrap="square" lIns="0" tIns="0" rIns="0" bIns="0" rtlCol="0" anchor="ctr"/>
+          <p:cNvPr id="4" name="Shape 1"/>
+          <p:cNvSpPr/>
+          <p:nvPr/>
+        </p:nvSpPr>
+        <p:spPr>
+          <a:xfrm>
+            <a:off x="548640" y="1143000"/>
+            <a:ext cx="11094415" cy="5257800"/>
+          </a:xfrm>
+          <a:prstGeom prst="roundRect">
+            <a:avLst>
+              <a:gd name="adj" fmla="val 3478"/>
+            </a:avLst>
+          </a:prstGeom>
+          <a:solidFill>
+            <a:srgbClr val="000000"/>
+          </a:solidFill>
+          <a:ln/>
+        </p:spPr>
+      </p:sp>
+      <p:sp>
+        <p:nvSpPr>
+          <p:cNvPr id="5" name="Text 2"/>
+          <p:cNvSpPr/>
+          <p:nvPr/>
+        </p:nvSpPr>
+        <p:spPr>
+          <a:xfrm>
+            <a:off x="960120" y="1508760"/>
+            <a:ext cx="5090008" cy="1371600"/>
+          </a:xfrm>
+          <a:prstGeom prst="rect">
+            <a:avLst/>
+          </a:prstGeom>
+          <a:noFill/>
+          <a:ln/>
+        </p:spPr>
+        <p:txBody>
+          <a:bodyPr wrap="square" lIns="0" tIns="0" rIns="0" bIns="0" rtlCol="0" anchor="t"/>
           <a:lstStyle/>
           <a:p>
             <a:pPr indent="0" marL="0">
               <a:buNone/>
             </a:pPr>
             <a:r>
-              <a:rPr lang="en-US" sz="2600" b="1" i="1" dirty="0">
-                <a:solidFill>
-                  <a:srgbClr val="000000"/>
+              <a:rPr lang="en-US" sz="2200" b="1" i="1" dirty="0">
+                <a:solidFill>
+                  <a:srgbClr val="DAFF94"/>
                 </a:solidFill>
                 <a:latin typeface="Libre Baskerville" pitchFamily="34" charset="0"/>
                 <a:ea typeface="Libre Baskerville" pitchFamily="34" charset="-122"/>
@@ -8896,20 +8918,20 @@
               </a:rPr>
               <a:t>O nosso diferencial: inteligência de mercado, todo mês.</a:t>
             </a:r>
-            <a:endParaRPr lang="en-US" sz="2600" dirty="0"/>
-          </a:p>
-        </p:txBody>
-      </p:sp>
-      <p:sp>
-        <p:nvSpPr>
-          <p:cNvPr id="5" name="Text 2"/>
-          <p:cNvSpPr/>
-          <p:nvPr/>
-        </p:nvSpPr>
-        <p:spPr>
-          <a:xfrm>
-            <a:off x="548640" y="2560320"/>
-            <a:ext cx="11094415" cy="2377440"/>
+            <a:endParaRPr lang="en-US" sz="2200" dirty="0"/>
+          </a:p>
+        </p:txBody>
+      </p:sp>
+      <p:sp>
+        <p:nvSpPr>
+          <p:cNvPr id="6" name="Text 3"/>
+          <p:cNvSpPr/>
+          <p:nvPr/>
+        </p:nvSpPr>
+        <p:spPr>
+          <a:xfrm>
+            <a:off x="960120" y="2971800"/>
+            <a:ext cx="5090008" cy="2743200"/>
           </a:xfrm>
           <a:prstGeom prst="rect">
             <a:avLst/>
@@ -8925,9 +8947,9 @@
               <a:buNone/>
             </a:pPr>
             <a:r>
-              <a:rPr lang="en-US" sz="1500" dirty="0">
-                <a:solidFill>
-                  <a:srgbClr val="222222"/>
+              <a:rPr lang="en-US" sz="1350" dirty="0">
+                <a:solidFill>
+                  <a:srgbClr val="FFFFFF"/>
                 </a:solidFill>
                 <a:latin typeface="Arial" pitchFamily="34" charset="0"/>
                 <a:ea typeface="Arial" pitchFamily="34" charset="-122"/>
@@ -8935,22 +8957,22 @@
               </a:rPr>
               <a:t>Isso que você viu até agora — leitura de tendências de consumo, novidades de plataformas e cases que inspiram — é o nosso .report: um relatório proprietário que produzimos todo mês pra orientar as decisões dos nossos clientes.</a:t>
             </a:r>
-            <a:endParaRPr lang="en-US" sz="1500" dirty="0"/>
+            <a:endParaRPr lang="en-US" sz="1350" dirty="0"/>
           </a:p>
           <a:p>
             <a:pPr indent="0" marL="0">
               <a:buNone/>
             </a:pPr>
-            <a:endParaRPr lang="en-US" sz="1500" dirty="0"/>
+            <a:endParaRPr lang="en-US" sz="1350" dirty="0"/>
           </a:p>
           <a:p>
             <a:pPr indent="0" marL="0">
               <a:buNone/>
             </a:pPr>
             <a:r>
-              <a:rPr lang="en-US" sz="1500" dirty="0">
-                <a:solidFill>
-                  <a:srgbClr val="222222"/>
+              <a:rPr lang="en-US" sz="1350" dirty="0">
+                <a:solidFill>
+                  <a:srgbClr val="FFFFFF"/>
                 </a:solidFill>
                 <a:latin typeface="Arial" pitchFamily="34" charset="0"/>
                 <a:ea typeface="Arial" pitchFamily="34" charset="-122"/>
@@ -8958,13 +8980,13 @@
               </a:rPr>
               <a:t>Quem fecha com a Arpejo não recebe só campanha. Recebe visão de mercado aplicada, com frequência mensal.</a:t>
             </a:r>
-            <a:endParaRPr lang="en-US" sz="1500" dirty="0"/>
+            <a:endParaRPr lang="en-US" sz="1350" dirty="0"/>
           </a:p>
         </p:txBody>
       </p:sp>
       <p:pic>
         <p:nvPicPr>
-          <p:cNvPr id="6" name="Image 1" descr="/home/user/data-manipulation-exercises/.claude/skills/brand-guidelines/assets/textures/arrow-black.png">    </p:cNvPr>
+          <p:cNvPr id="7" name="Image 1" descr="/tmp/claude-0/-home-user-data-manipulation-exercises/f19acac8-ccb4-5197-8e49-c3b6029ad477/scratchpad/report-images/final/prospect-diferencial.jpg">    </p:cNvPr>
           <p:cNvPicPr>
             <a:picLocks noChangeAspect="1"/>
           </p:cNvPicPr>
@@ -8972,6 +8994,29 @@
         </p:nvPicPr>
         <p:blipFill>
           <a:blip r:embed="rId2"/>
+          <a:srcRect l="0" r="0" t="0" b="0"/>
+          <a:stretch/>
+        </p:blipFill>
+        <p:spPr>
+          <a:xfrm>
+            <a:off x="6461608" y="1463040"/>
+            <a:ext cx="4861408" cy="4617720"/>
+          </a:xfrm>
+          <a:prstGeom prst="rect">
+            <a:avLst/>
+          </a:prstGeom>
+        </p:spPr>
+      </p:pic>
+      <p:pic>
+        <p:nvPicPr>
+          <p:cNvPr id="8" name="Image 2" descr="/tmp/claude-0/-home-user-data-manipulation-exercises/f19acac8-ccb4-5197-8e49-c3b6029ad477/scratchpad/texture-check/assets/arrow-black.png">    </p:cNvPr>
+          <p:cNvPicPr>
+            <a:picLocks noChangeAspect="1"/>
+          </p:cNvPicPr>
+          <p:nvPr/>
+        </p:nvPicPr>
+        <p:blipFill>
+          <a:blip r:embed="rId3"/>
           <a:stretch>
             <a:fillRect/>
           </a:stretch>
@@ -10580,7 +10625,7 @@
       </p:sp>
       <p:pic>
         <p:nvPicPr>
-          <p:cNvPr id="42" name="Image 0" descr="/home/user/data-manipulation-exercises/.claude/skills/brand-guidelines/assets/textures/arrow-lime.png">    </p:cNvPr>
+          <p:cNvPr id="42" name="Image 0" descr="/tmp/claude-0/-home-user-data-manipulation-exercises/f19acac8-ccb4-5197-8e49-c3b6029ad477/scratchpad/texture-check/assets/arrow-lime.png">    </p:cNvPr>
           <p:cNvPicPr>
             <a:picLocks noChangeAspect="1"/>
           </p:cNvPicPr>
@@ -10604,7 +10649,7 @@
       </p:pic>
       <p:pic>
         <p:nvPicPr>
-          <p:cNvPr id="43" name="Image 1" descr="/home/user/data-manipulation-exercises/.claude/skills/brand-guidelines/assets/textures/arrow-lime.png">    </p:cNvPr>
+          <p:cNvPr id="43" name="Image 1" descr="/tmp/claude-0/-home-user-data-manipulation-exercises/f19acac8-ccb4-5197-8e49-c3b6029ad477/scratchpad/texture-check/assets/arrow-lime.png">    </p:cNvPr>
           <p:cNvPicPr>
             <a:picLocks noChangeAspect="1"/>
           </p:cNvPicPr>
@@ -10628,7 +10673,7 @@
       </p:pic>
       <p:pic>
         <p:nvPicPr>
-          <p:cNvPr id="44" name="Image 2" descr="/home/user/data-manipulation-exercises/.claude/skills/brand-guidelines/assets/textures/arrow-lime.png">    </p:cNvPr>
+          <p:cNvPr id="44" name="Image 2" descr="/tmp/claude-0/-home-user-data-manipulation-exercises/f19acac8-ccb4-5197-8e49-c3b6029ad477/scratchpad/texture-check/assets/arrow-lime.png">    </p:cNvPr>
           <p:cNvPicPr>
             <a:picLocks noChangeAspect="1"/>
           </p:cNvPicPr>
@@ -10652,7 +10697,7 @@
       </p:pic>
       <p:pic>
         <p:nvPicPr>
-          <p:cNvPr id="45" name="Image 3" descr="/home/user/data-manipulation-exercises/.claude/skills/brand-guidelines/assets/textures/arrow-lime.png">    </p:cNvPr>
+          <p:cNvPr id="45" name="Image 3" descr="/tmp/claude-0/-home-user-data-manipulation-exercises/f19acac8-ccb4-5197-8e49-c3b6029ad477/scratchpad/texture-check/assets/arrow-lime.png">    </p:cNvPr>
           <p:cNvPicPr>
             <a:picLocks noChangeAspect="1"/>
           </p:cNvPicPr>
@@ -10788,7 +10833,7 @@
       </p:sp>
       <p:pic>
         <p:nvPicPr>
-          <p:cNvPr id="48" name="Image 4" descr="/home/user/data-manipulation-exercises/.claude/skills/arpejo-report-desdobramento/assets/arpejo-report-logo.png">    </p:cNvPr>
+          <p:cNvPr id="48" name="Image 4" descr="../assets/arpejo-report-logo-all-black.png">    </p:cNvPr>
           <p:cNvPicPr>
             <a:picLocks noChangeAspect="1"/>
           </p:cNvPicPr>

</xml_diff>

<commit_message>
Corrige distorção de fotos nos três materiais do .report
O sizing "cover" do pptxgenjs (4.0.1) calcula o corte usando as próprias
dimensões da caixa de destino em vez das dimensões reais da imagem, o que
sempre resultava em corte zero (esticamento simples) sempre que a proporção
da foto não batia exatamente com a da caixa. Adiciona addCoverImage() em
lib/identity.js, que lê as dimensões reais do arquivo (image-size) e contorna
o bug, e troca todos os addImage+sizing:cover do carrossel e da prospecção
para usá-lo. Regenera os três .pptx de entrega com o corte correto.
</commit_message>
<xml_diff>
--- a/entregas-agosto26/apresentacao-prospeccao-agosto26.pptx
+++ b/entregas-agosto26/apresentacao-prospeccao-agosto26.pptx
@@ -4242,7 +4242,7 @@
         </p:nvPicPr>
         <p:blipFill>
           <a:blip r:embed="rId2"/>
-          <a:srcRect l="0" r="0" t="0" b="0"/>
+          <a:srcRect l="15170" r="15170" t="0" b="0"/>
           <a:stretch/>
         </p:blipFill>
         <p:spPr>
@@ -4817,7 +4817,7 @@
         </p:nvPicPr>
         <p:blipFill>
           <a:blip r:embed="rId2"/>
-          <a:srcRect l="0" r="0" t="0" b="0"/>
+          <a:srcRect l="3113" r="3113" t="0" b="0"/>
           <a:stretch/>
         </p:blipFill>
         <p:spPr>
@@ -8994,7 +8994,7 @@
         </p:nvPicPr>
         <p:blipFill>
           <a:blip r:embed="rId2"/>
-          <a:srcRect l="0" r="0" t="0" b="0"/>
+          <a:srcRect l="15127" r="15127" t="0" b="0"/>
           <a:stretch/>
         </p:blipFill>
         <p:spPr>

</xml_diff>